<commit_message>
Sync contest to main d7664dc: add deck PDF, updated source and manifest
</commit_message>
<xml_diff>
--- a/submissions/Track2-Physics-First-AI-NuclidePath/source/submission/NuclidePath_Track2_Deck.pptx
+++ b/submissions/Track2-Physics-First-AI-NuclidePath/source/submission/NuclidePath_Track2_Deck.pptx
@@ -8573,7 +8573,7 @@
                 <a:ea typeface="Liberation Sans" pitchFamily="34" charset="-122"/>
                 <a:cs typeface="Liberation Sans" pitchFamily="34" charset="-120"/>
               </a:rPr>
-              <a:t>231 AMD core tests + FP64 parity + SHA-256</a:t>
+              <a:t>388 AMD post-merge tests + FP64 parity + SHA-256</a:t>
             </a:r>
             <a:endParaRPr lang="en-US" sz="1600" dirty="0"/>
           </a:p>
@@ -8926,7 +8926,7 @@
                 <a:ea typeface="Liberation Mono" pitchFamily="34" charset="-122"/>
                 <a:cs typeface="Liberation Mono" pitchFamily="34" charset="-120"/>
               </a:rPr>
-              <a:t>231</a:t>
+              <a:t>388</a:t>
             </a:r>
             <a:endParaRPr lang="en-US" sz="3600" dirty="0"/>
           </a:p>
@@ -8967,7 +8967,7 @@
                 <a:ea typeface="Liberation Sans" pitchFamily="34" charset="-122"/>
                 <a:cs typeface="Liberation Sans" pitchFamily="34" charset="-120"/>
               </a:rPr>
-              <a:t>AMD core tests</a:t>
+              <a:t>AMD tests (post-merge)</a:t>
             </a:r>
             <a:endParaRPr lang="en-US" sz="1100" dirty="0"/>
           </a:p>

</xml_diff>